<commit_message>
Gantt: keep activity descriptions visible when rows get compact; include them in PPT export
Co-Authored-By: Claude Sonnet 5.5 <noreply@anthropic.com>
Claude-Session: https://claude.ai/code/session_015CooLRRU7X55XCWBXAPEMd
</commit_message>
<xml_diff>
--- a/ufwl-timeline/UFWL_Gantt_AR_sample.pptx
+++ b/ufwl-timeline/UFWL_Gantt_AR_sample.pptx
@@ -9149,7 +9149,10 @@
           </a:bodyPr>
           <a:lstStyle/>
           <a:p>
-            <a:pPr rtl="1" algn="r" indent="0" marL="0">
+            <a:pPr algn="r" indent="0" marL="0">
+              <a:lnSpc>
+                <a:spcPct val="85000"/>
+              </a:lnSpc>
               <a:buNone/>
             </a:pPr>
             <a:r>
@@ -9162,6 +9165,26 @@
                 <a:cs typeface="Arial" pitchFamily="34" charset="-120"/>
               </a:rPr>
               <a:t>طلب تصريح العمل</a:t>
+            </a:r>
+            <a:endParaRPr lang="ar-SA" sz="800" dirty="0"/>
+          </a:p>
+          <a:p>
+            <a:pPr algn="r" indent="0" marL="0">
+              <a:lnSpc>
+                <a:spcPct val="85000"/>
+              </a:lnSpc>
+              <a:buNone/>
+            </a:pPr>
+            <a:r>
+              <a:rPr lang="ar-SA" altLang="en-US" sz="550" dirty="0">
+                <a:solidFill>
+                  <a:srgbClr val="66707A"/>
+                </a:solidFill>
+                <a:latin typeface="Arial" pitchFamily="34" charset="0"/>
+                <a:ea typeface="Arial" pitchFamily="34" charset="-122"/>
+                <a:cs typeface="Arial" pitchFamily="34" charset="-120"/>
+              </a:rPr>
+              <a:t>طلب تصريح لتنفيذ أعمال الأساسات لإزالة خطر انهيار التربة.</a:t>
             </a:r>
             <a:endParaRPr lang="ar-SA" sz="800" dirty="0"/>
           </a:p>
@@ -9473,7 +9496,10 @@
           </a:bodyPr>
           <a:lstStyle/>
           <a:p>
-            <a:pPr rtl="1" algn="r" indent="0" marL="0">
+            <a:pPr algn="r" indent="0" marL="0">
+              <a:lnSpc>
+                <a:spcPct val="85000"/>
+              </a:lnSpc>
               <a:buNone/>
             </a:pPr>
             <a:r>
@@ -9486,6 +9512,26 @@
                 <a:cs typeface="Arial" pitchFamily="34" charset="-120"/>
               </a:rPr>
               <a:t>رفض طلب التصريح</a:t>
+            </a:r>
+            <a:endParaRPr lang="ar-SA" sz="800" dirty="0"/>
+          </a:p>
+          <a:p>
+            <a:pPr algn="r" indent="0" marL="0">
+              <a:lnSpc>
+                <a:spcPct val="85000"/>
+              </a:lnSpc>
+              <a:buNone/>
+            </a:pPr>
+            <a:r>
+              <a:rPr lang="ar-SA" altLang="en-US" sz="550" dirty="0">
+                <a:solidFill>
+                  <a:srgbClr val="66707A"/>
+                </a:solidFill>
+                <a:latin typeface="Arial" pitchFamily="34" charset="0"/>
+                <a:ea typeface="Arial" pitchFamily="34" charset="-122"/>
+                <a:cs typeface="Arial" pitchFamily="34" charset="-120"/>
+              </a:rPr>
+              <a:t>رفضت إدارة التصاريح طلب تصريح العمل.</a:t>
             </a:r>
             <a:endParaRPr lang="ar-SA" sz="800" dirty="0"/>
           </a:p>
@@ -9919,7 +9965,10 @@
           </a:bodyPr>
           <a:lstStyle/>
           <a:p>
-            <a:pPr rtl="1" algn="r" indent="0" marL="0">
+            <a:pPr algn="r" indent="0" marL="0">
+              <a:lnSpc>
+                <a:spcPct val="85000"/>
+              </a:lnSpc>
               <a:buNone/>
             </a:pPr>
             <a:r>
@@ -9932,6 +9981,26 @@
                 <a:cs typeface="Arial" pitchFamily="34" charset="-120"/>
               </a:rPr>
               <a:t>إيقاف أنشطة المشروع</a:t>
+            </a:r>
+            <a:endParaRPr lang="ar-SA" sz="800" dirty="0"/>
+          </a:p>
+          <a:p>
+            <a:pPr algn="r" indent="0" marL="0">
+              <a:lnSpc>
+                <a:spcPct val="85000"/>
+              </a:lnSpc>
+              <a:buNone/>
+            </a:pPr>
+            <a:r>
+              <a:rPr lang="ar-SA" altLang="en-US" sz="550" dirty="0">
+                <a:solidFill>
+                  <a:srgbClr val="66707A"/>
+                </a:solidFill>
+                <a:latin typeface="Arial" pitchFamily="34" charset="0"/>
+                <a:ea typeface="Arial" pitchFamily="34" charset="-122"/>
+                <a:cs typeface="Arial" pitchFamily="34" charset="-120"/>
+              </a:rPr>
+              <a:t>أوقفت إدارة التصاريح والسلامة جميع أنشطة المشروع بالموقع.</a:t>
             </a:r>
             <a:endParaRPr lang="ar-SA" sz="800" dirty="0"/>
           </a:p>
@@ -10243,7 +10312,10 @@
           </a:bodyPr>
           <a:lstStyle/>
           <a:p>
-            <a:pPr rtl="1" algn="r" indent="0" marL="0">
+            <a:pPr algn="r" indent="0" marL="0">
+              <a:lnSpc>
+                <a:spcPct val="85000"/>
+              </a:lnSpc>
               <a:buNone/>
             </a:pPr>
             <a:r>
@@ -10256,6 +10328,26 @@
                 <a:cs typeface="Arial" pitchFamily="34" charset="-120"/>
               </a:rPr>
               <a:t>زيارة ميدانية مشتركة</a:t>
+            </a:r>
+            <a:endParaRPr lang="ar-SA" sz="800" dirty="0"/>
+          </a:p>
+          <a:p>
+            <a:pPr algn="r" indent="0" marL="0">
+              <a:lnSpc>
+                <a:spcPct val="85000"/>
+              </a:lnSpc>
+              <a:buNone/>
+            </a:pPr>
+            <a:r>
+              <a:rPr lang="ar-SA" altLang="en-US" sz="550" dirty="0">
+                <a:solidFill>
+                  <a:srgbClr val="66707A"/>
+                </a:solidFill>
+                <a:latin typeface="Arial" pitchFamily="34" charset="0"/>
+                <a:ea typeface="Arial" pitchFamily="34" charset="-122"/>
+                <a:cs typeface="Arial" pitchFamily="34" charset="-120"/>
+              </a:rPr>
+              <a:t>زيارة مشتركة مع الإدارات المعنية (التصاريح وغيرها) لتقييم حالة الموقع.</a:t>
             </a:r>
             <a:endParaRPr lang="ar-SA" sz="800" dirty="0"/>
           </a:p>
@@ -10567,7 +10659,10 @@
           </a:bodyPr>
           <a:lstStyle/>
           <a:p>
-            <a:pPr rtl="1" algn="r" indent="0" marL="0">
+            <a:pPr algn="r" indent="0" marL="0">
+              <a:lnSpc>
+                <a:spcPct val="85000"/>
+              </a:lnSpc>
               <a:buNone/>
             </a:pPr>
             <a:r>
@@ -10580,6 +10675,26 @@
                 <a:cs typeface="Arial" pitchFamily="34" charset="-120"/>
               </a:rPr>
               <a:t>تقديم تقييم المخاطر وخطة التخفيف</a:t>
+            </a:r>
+            <a:endParaRPr lang="ar-SA" sz="800" dirty="0"/>
+          </a:p>
+          <a:p>
+            <a:pPr algn="r" indent="0" marL="0">
+              <a:lnSpc>
+                <a:spcPct val="85000"/>
+              </a:lnSpc>
+              <a:buNone/>
+            </a:pPr>
+            <a:r>
+              <a:rPr lang="ar-SA" altLang="en-US" sz="550" dirty="0">
+                <a:solidFill>
+                  <a:srgbClr val="66707A"/>
+                </a:solidFill>
+                <a:latin typeface="Arial" pitchFamily="34" charset="0"/>
+                <a:ea typeface="Arial" pitchFamily="34" charset="-122"/>
+                <a:cs typeface="Arial" pitchFamily="34" charset="-120"/>
+              </a:rPr>
+              <a:t>أُرسلت إلى إدارة التصاريح بهدف استئناف العمل.</a:t>
             </a:r>
             <a:endParaRPr lang="ar-SA" sz="800" dirty="0"/>
           </a:p>
@@ -10891,7 +11006,10 @@
           </a:bodyPr>
           <a:lstStyle/>
           <a:p>
-            <a:pPr rtl="1" algn="r" indent="0" marL="0">
+            <a:pPr algn="r" indent="0" marL="0">
+              <a:lnSpc>
+                <a:spcPct val="85000"/>
+              </a:lnSpc>
               <a:buNone/>
             </a:pPr>
             <a:r>
@@ -10904,6 +11022,26 @@
                 <a:cs typeface="Arial" pitchFamily="34" charset="-120"/>
               </a:rPr>
               <a:t>طلب خطة عمل تفصيلية</a:t>
+            </a:r>
+            <a:endParaRPr lang="ar-SA" sz="800" dirty="0"/>
+          </a:p>
+          <a:p>
+            <a:pPr algn="r" indent="0" marL="0">
+              <a:lnSpc>
+                <a:spcPct val="85000"/>
+              </a:lnSpc>
+              <a:buNone/>
+            </a:pPr>
+            <a:r>
+              <a:rPr lang="ar-SA" altLang="en-US" sz="550" dirty="0">
+                <a:solidFill>
+                  <a:srgbClr val="66707A"/>
+                </a:solidFill>
+                <a:latin typeface="Arial" pitchFamily="34" charset="0"/>
+                <a:ea typeface="Arial" pitchFamily="34" charset="-122"/>
+                <a:cs typeface="Arial" pitchFamily="34" charset="-120"/>
+              </a:rPr>
+              <a:t>طلبت إدارة التصاريح خطة عمل أكثر تفصيلاً.</a:t>
             </a:r>
             <a:endParaRPr lang="ar-SA" sz="800" dirty="0"/>
           </a:p>
@@ -11337,7 +11475,10 @@
           </a:bodyPr>
           <a:lstStyle/>
           <a:p>
-            <a:pPr rtl="1" algn="r" indent="0" marL="0">
+            <a:pPr algn="r" indent="0" marL="0">
+              <a:lnSpc>
+                <a:spcPct val="85000"/>
+              </a:lnSpc>
               <a:buNone/>
             </a:pPr>
             <a:r>
@@ -11350,6 +11491,26 @@
                 <a:cs typeface="Arial" pitchFamily="34" charset="-120"/>
               </a:rPr>
               <a:t>تقديم بيان طريقة العمل (MoS)</a:t>
+            </a:r>
+            <a:endParaRPr lang="ar-SA" sz="800" dirty="0"/>
+          </a:p>
+          <a:p>
+            <a:pPr algn="r" indent="0" marL="0">
+              <a:lnSpc>
+                <a:spcPct val="85000"/>
+              </a:lnSpc>
+              <a:buNone/>
+            </a:pPr>
+            <a:r>
+              <a:rPr lang="ar-SA" altLang="en-US" sz="550" dirty="0">
+                <a:solidFill>
+                  <a:srgbClr val="66707A"/>
+                </a:solidFill>
+                <a:latin typeface="Arial" pitchFamily="34" charset="0"/>
+                <a:ea typeface="Arial" pitchFamily="34" charset="-122"/>
+                <a:cs typeface="Arial" pitchFamily="34" charset="-120"/>
+              </a:rPr>
+              <a:t>بيان طريقة العمل وخطة العمل التفصيلية لجميع الإدارات للمراجعة والاعتماد.</a:t>
             </a:r>
             <a:endParaRPr lang="ar-SA" sz="800" dirty="0"/>
           </a:p>
@@ -11589,7 +11750,10 @@
           </a:bodyPr>
           <a:lstStyle/>
           <a:p>
-            <a:pPr rtl="1" algn="r" indent="0" marL="0">
+            <a:pPr algn="r" indent="0" marL="0">
+              <a:lnSpc>
+                <a:spcPct val="85000"/>
+              </a:lnSpc>
               <a:buNone/>
             </a:pPr>
             <a:r>
@@ -11602,6 +11766,26 @@
                 <a:cs typeface="Arial" pitchFamily="34" charset="-120"/>
               </a:rPr>
               <a:t>اجتماع أصحاب المصلحة</a:t>
+            </a:r>
+            <a:endParaRPr lang="ar-SA" sz="800" dirty="0"/>
+          </a:p>
+          <a:p>
+            <a:pPr algn="r" indent="0" marL="0">
+              <a:lnSpc>
+                <a:spcPct val="85000"/>
+              </a:lnSpc>
+              <a:buNone/>
+            </a:pPr>
+            <a:r>
+              <a:rPr lang="ar-SA" altLang="en-US" sz="550" dirty="0">
+                <a:solidFill>
+                  <a:srgbClr val="66707A"/>
+                </a:solidFill>
+                <a:latin typeface="Arial" pitchFamily="34" charset="0"/>
+                <a:ea typeface="Arial" pitchFamily="34" charset="-122"/>
+                <a:cs typeface="Arial" pitchFamily="34" charset="-120"/>
+              </a:rPr>
+              <a:t>الاتفاق على المضي قدماً وطلب مراجعة الإجراءات واعتمادها من الإدارات.</a:t>
             </a:r>
             <a:endParaRPr lang="ar-SA" sz="800" dirty="0"/>
           </a:p>
@@ -11913,7 +12097,10 @@
           </a:bodyPr>
           <a:lstStyle/>
           <a:p>
-            <a:pPr rtl="1" algn="r" indent="0" marL="0">
+            <a:pPr algn="r" indent="0" marL="0">
+              <a:lnSpc>
+                <a:spcPct val="85000"/>
+              </a:lnSpc>
               <a:buNone/>
             </a:pPr>
             <a:r>
@@ -11926,6 +12113,26 @@
                 <a:cs typeface="Arial" pitchFamily="34" charset="-120"/>
               </a:rPr>
               <a:t>الرد على استفسارات أصحاب المصلحة</a:t>
+            </a:r>
+            <a:endParaRPr lang="ar-SA" sz="800" dirty="0"/>
+          </a:p>
+          <a:p>
+            <a:pPr algn="r" indent="0" marL="0">
+              <a:lnSpc>
+                <a:spcPct val="85000"/>
+              </a:lnSpc>
+              <a:buNone/>
+            </a:pPr>
+            <a:r>
+              <a:rPr lang="ar-SA" altLang="en-US" sz="550" dirty="0">
+                <a:solidFill>
+                  <a:srgbClr val="66707A"/>
+                </a:solidFill>
+                <a:latin typeface="Arial" pitchFamily="34" charset="0"/>
+                <a:ea typeface="Arial" pitchFamily="34" charset="-122"/>
+                <a:cs typeface="Arial" pitchFamily="34" charset="-120"/>
+              </a:rPr>
+              <a:t>تم الرد على كل الاستفسارات بشأن الأعمال وإجراءات السلامة.</a:t>
             </a:r>
             <a:endParaRPr lang="ar-SA" sz="800" dirty="0"/>
           </a:p>
@@ -12237,7 +12444,10 @@
           </a:bodyPr>
           <a:lstStyle/>
           <a:p>
-            <a:pPr rtl="1" algn="r" indent="0" marL="0">
+            <a:pPr algn="r" indent="0" marL="0">
+              <a:lnSpc>
+                <a:spcPct val="85000"/>
+              </a:lnSpc>
               <a:buNone/>
             </a:pPr>
             <a:r>
@@ -12250,6 +12460,26 @@
                 <a:cs typeface="Arial" pitchFamily="34" charset="-120"/>
               </a:rPr>
               <a:t>استلام توضيح من إدارة الهندسة</a:t>
+            </a:r>
+            <a:endParaRPr lang="ar-SA" sz="800" dirty="0"/>
+          </a:p>
+          <a:p>
+            <a:pPr algn="r" indent="0" marL="0">
+              <a:lnSpc>
+                <a:spcPct val="85000"/>
+              </a:lnSpc>
+              <a:buNone/>
+            </a:pPr>
+            <a:r>
+              <a:rPr lang="ar-SA" altLang="en-US" sz="550" dirty="0">
+                <a:solidFill>
+                  <a:srgbClr val="66707A"/>
+                </a:solidFill>
+                <a:latin typeface="Arial" pitchFamily="34" charset="0"/>
+                <a:ea typeface="Arial" pitchFamily="34" charset="-122"/>
+                <a:cs typeface="Arial" pitchFamily="34" charset="-120"/>
+              </a:rPr>
+              <a:t>أثارت إدارة الهندسة استيضاحاً على بيان طريقة العمل.</a:t>
             </a:r>
             <a:endParaRPr lang="ar-SA" sz="800" dirty="0"/>
           </a:p>
@@ -12561,7 +12791,10 @@
           </a:bodyPr>
           <a:lstStyle/>
           <a:p>
-            <a:pPr rtl="1" algn="r" indent="0" marL="0">
+            <a:pPr algn="r" indent="0" marL="0">
+              <a:lnSpc>
+                <a:spcPct val="85000"/>
+              </a:lnSpc>
               <a:buNone/>
             </a:pPr>
             <a:r>
@@ -12574,6 +12807,26 @@
                 <a:cs typeface="Arial" pitchFamily="34" charset="-120"/>
               </a:rPr>
               <a:t>تقديم المراجعة الثانية (MoS)</a:t>
+            </a:r>
+            <a:endParaRPr lang="ar-SA" sz="800" dirty="0"/>
+          </a:p>
+          <a:p>
+            <a:pPr algn="r" indent="0" marL="0">
+              <a:lnSpc>
+                <a:spcPct val="85000"/>
+              </a:lnSpc>
+              <a:buNone/>
+            </a:pPr>
+            <a:r>
+              <a:rPr lang="ar-SA" altLang="en-US" sz="550" dirty="0">
+                <a:solidFill>
+                  <a:srgbClr val="66707A"/>
+                </a:solidFill>
+                <a:latin typeface="Arial" pitchFamily="34" charset="0"/>
+                <a:ea typeface="Arial" pitchFamily="34" charset="-122"/>
+                <a:cs typeface="Arial" pitchFamily="34" charset="-120"/>
+              </a:rPr>
+              <a:t>قُدّمت المراجعة الثانية للبيان إلى جميع الإدارات المعنية.</a:t>
             </a:r>
             <a:endParaRPr lang="ar-SA" sz="800" dirty="0"/>
           </a:p>
@@ -13007,7 +13260,10 @@
           </a:bodyPr>
           <a:lstStyle/>
           <a:p>
-            <a:pPr rtl="1" algn="r" indent="0" marL="0">
+            <a:pPr algn="r" indent="0" marL="0">
+              <a:lnSpc>
+                <a:spcPct val="85000"/>
+              </a:lnSpc>
               <a:buNone/>
             </a:pPr>
             <a:r>
@@ -13020,6 +13276,26 @@
                 <a:cs typeface="Arial" pitchFamily="34" charset="-120"/>
               </a:rPr>
               <a:t>التواصل مع إدارة السلامة</a:t>
+            </a:r>
+            <a:endParaRPr lang="ar-SA" sz="800" dirty="0"/>
+          </a:p>
+          <a:p>
+            <a:pPr algn="r" indent="0" marL="0">
+              <a:lnSpc>
+                <a:spcPct val="85000"/>
+              </a:lnSpc>
+              <a:buNone/>
+            </a:pPr>
+            <a:r>
+              <a:rPr lang="ar-SA" altLang="en-US" sz="550" dirty="0">
+                <a:solidFill>
+                  <a:srgbClr val="66707A"/>
+                </a:solidFill>
+                <a:latin typeface="Arial" pitchFamily="34" charset="0"/>
+                <a:ea typeface="Arial" pitchFamily="34" charset="-122"/>
+                <a:cs typeface="Arial" pitchFamily="34" charset="-120"/>
+              </a:rPr>
+              <a:t>بعد مشاركة المستندات تم التواصل مع السلامة لتسهيل إصدار التصريح.</a:t>
             </a:r>
             <a:endParaRPr lang="ar-SA" sz="800" dirty="0"/>
           </a:p>
@@ -13331,7 +13607,10 @@
           </a:bodyPr>
           <a:lstStyle/>
           <a:p>
-            <a:pPr rtl="1" algn="r" indent="0" marL="0">
+            <a:pPr algn="r" indent="0" marL="0">
+              <a:lnSpc>
+                <a:spcPct val="85000"/>
+              </a:lnSpc>
               <a:buNone/>
             </a:pPr>
             <a:r>
@@ -13344,6 +13623,26 @@
                 <a:cs typeface="Arial" pitchFamily="34" charset="-120"/>
               </a:rPr>
               <a:t>تعميم التصريح للموافقات</a:t>
+            </a:r>
+            <a:endParaRPr lang="ar-SA" sz="800" dirty="0"/>
+          </a:p>
+          <a:p>
+            <a:pPr algn="r" indent="0" marL="0">
+              <a:lnSpc>
+                <a:spcPct val="85000"/>
+              </a:lnSpc>
+              <a:buNone/>
+            </a:pPr>
+            <a:r>
+              <a:rPr lang="ar-SA" altLang="en-US" sz="550" dirty="0">
+                <a:solidFill>
+                  <a:srgbClr val="66707A"/>
+                </a:solidFill>
+                <a:latin typeface="Arial" pitchFamily="34" charset="0"/>
+                <a:ea typeface="Arial" pitchFamily="34" charset="-122"/>
+                <a:cs typeface="Arial" pitchFamily="34" charset="-120"/>
+              </a:rPr>
+              <a:t>أُرسل تصريح العمل للإدارات المعنية للموافقة عليه.</a:t>
             </a:r>
             <a:endParaRPr lang="ar-SA" sz="800" dirty="0"/>
           </a:p>
@@ -13655,7 +13954,10 @@
           </a:bodyPr>
           <a:lstStyle/>
           <a:p>
-            <a:pPr rtl="1" algn="r" indent="0" marL="0">
+            <a:pPr algn="r" indent="0" marL="0">
+              <a:lnSpc>
+                <a:spcPct val="85000"/>
+              </a:lnSpc>
               <a:buNone/>
             </a:pPr>
             <a:r>
@@ -13668,6 +13970,26 @@
                 <a:cs typeface="Arial" pitchFamily="34" charset="-120"/>
               </a:rPr>
               <a:t>ملاحظات إضافية من الإدارات</a:t>
+            </a:r>
+            <a:endParaRPr lang="ar-SA" sz="800" dirty="0"/>
+          </a:p>
+          <a:p>
+            <a:pPr algn="r" indent="0" marL="0">
+              <a:lnSpc>
+                <a:spcPct val="85000"/>
+              </a:lnSpc>
+              <a:buNone/>
+            </a:pPr>
+            <a:r>
+              <a:rPr lang="ar-SA" altLang="en-US" sz="550" dirty="0">
+                <a:solidFill>
+                  <a:srgbClr val="66707A"/>
+                </a:solidFill>
+                <a:latin typeface="Arial" pitchFamily="34" charset="0"/>
+                <a:ea typeface="Arial" pitchFamily="34" charset="-122"/>
+                <a:cs typeface="Arial" pitchFamily="34" charset="-120"/>
+              </a:rPr>
+              <a:t>وردت ملاحظات إضافية من إدارات أخرى.</a:t>
             </a:r>
             <a:endParaRPr lang="ar-SA" sz="800" dirty="0"/>
           </a:p>
@@ -13979,7 +14301,10 @@
           </a:bodyPr>
           <a:lstStyle/>
           <a:p>
-            <a:pPr rtl="1" algn="r" indent="0" marL="0">
+            <a:pPr algn="r" indent="0" marL="0">
+              <a:lnSpc>
+                <a:spcPct val="85000"/>
+              </a:lnSpc>
               <a:buNone/>
             </a:pPr>
             <a:r>
@@ -13992,6 +14317,26 @@
                 <a:cs typeface="Arial" pitchFamily="34" charset="-120"/>
               </a:rPr>
               <a:t>تقديم المراجعة الثالثة (MoS)</a:t>
+            </a:r>
+            <a:endParaRPr lang="ar-SA" sz="800" dirty="0"/>
+          </a:p>
+          <a:p>
+            <a:pPr algn="r" indent="0" marL="0">
+              <a:lnSpc>
+                <a:spcPct val="85000"/>
+              </a:lnSpc>
+              <a:buNone/>
+            </a:pPr>
+            <a:r>
+              <a:rPr lang="ar-SA" altLang="en-US" sz="550" dirty="0">
+                <a:solidFill>
+                  <a:srgbClr val="66707A"/>
+                </a:solidFill>
+                <a:latin typeface="Arial" pitchFamily="34" charset="0"/>
+                <a:ea typeface="Arial" pitchFamily="34" charset="-122"/>
+                <a:cs typeface="Arial" pitchFamily="34" charset="-120"/>
+              </a:rPr>
+              <a:t>قُدّمت المراجعة الثالثة للبيان للجميع للاعتماد.</a:t>
             </a:r>
             <a:endParaRPr lang="ar-SA" sz="800" dirty="0"/>
           </a:p>
@@ -14303,7 +14648,10 @@
           </a:bodyPr>
           <a:lstStyle/>
           <a:p>
-            <a:pPr rtl="1" algn="r" indent="0" marL="0">
+            <a:pPr algn="r" indent="0" marL="0">
+              <a:lnSpc>
+                <a:spcPct val="85000"/>
+              </a:lnSpc>
               <a:buNone/>
             </a:pPr>
             <a:r>
@@ -14316,6 +14664,26 @@
                 <a:cs typeface="Arial" pitchFamily="34" charset="-120"/>
               </a:rPr>
               <a:t>إغلاق الاستفسار الأخير</a:t>
+            </a:r>
+            <a:endParaRPr lang="ar-SA" sz="800" dirty="0"/>
+          </a:p>
+          <a:p>
+            <a:pPr algn="r" indent="0" marL="0">
+              <a:lnSpc>
+                <a:spcPct val="85000"/>
+              </a:lnSpc>
+              <a:buNone/>
+            </a:pPr>
+            <a:r>
+              <a:rPr lang="ar-SA" altLang="en-US" sz="550" dirty="0">
+                <a:solidFill>
+                  <a:srgbClr val="66707A"/>
+                </a:solidFill>
+                <a:latin typeface="Arial" pitchFamily="34" charset="0"/>
+                <a:ea typeface="Arial" pitchFamily="34" charset="-122"/>
+                <a:cs typeface="Arial" pitchFamily="34" charset="-120"/>
+              </a:rPr>
+              <a:t>تم إغلاق الاستفسار المتبقي بشأن بيان طريقة العمل.</a:t>
             </a:r>
             <a:endParaRPr lang="ar-SA" sz="800" dirty="0"/>
           </a:p>
@@ -14627,7 +14995,10 @@
           </a:bodyPr>
           <a:lstStyle/>
           <a:p>
-            <a:pPr rtl="1" algn="r" indent="0" marL="0">
+            <a:pPr algn="r" indent="0" marL="0">
+              <a:lnSpc>
+                <a:spcPct val="85000"/>
+              </a:lnSpc>
               <a:buNone/>
             </a:pPr>
             <a:r>
@@ -14640,6 +15011,26 @@
                 <a:cs typeface="Arial" pitchFamily="34" charset="-120"/>
               </a:rPr>
               <a:t>تصريح العمل جاهز للتوقيع</a:t>
+            </a:r>
+            <a:endParaRPr lang="ar-SA" sz="800" dirty="0"/>
+          </a:p>
+          <a:p>
+            <a:pPr algn="r" indent="0" marL="0">
+              <a:lnSpc>
+                <a:spcPct val="85000"/>
+              </a:lnSpc>
+              <a:buNone/>
+            </a:pPr>
+            <a:r>
+              <a:rPr lang="ar-SA" altLang="en-US" sz="550" dirty="0">
+                <a:solidFill>
+                  <a:srgbClr val="66707A"/>
+                </a:solidFill>
+                <a:latin typeface="Arial" pitchFamily="34" charset="0"/>
+                <a:ea typeface="Arial" pitchFamily="34" charset="-122"/>
+                <a:cs typeface="Arial" pitchFamily="34" charset="-120"/>
+              </a:rPr>
+              <a:t>أصبح تصريح العمل جاهزاً للتوقيع والإصدار.</a:t>
             </a:r>
             <a:endParaRPr lang="ar-SA" sz="800" dirty="0"/>
           </a:p>

</xml_diff>